<commit_message>
Strip entrance animations from decks 03 and 10
PowerPoint flagged 10_marketing_campaign.pptx as needing repair.
Both decks were the only ones using power_pptx.animation, which
is currently producing OOXML that PowerPoint won't play and in
some combinations rejects outright.

- 03_product_launch: drop the sequenced fade on the introducing
  slide and the chart-shape fade on the benchmarks slide. Keep
  the per-slide Morph transition (transitions are unaffected).
- 10_marketing_campaign: drop the head/sub fade pair on the
  big-idea slide. Keep the per-slide Morph.
- README: note that entrance animations are intentionally not
  exercised here while the animation playback issue is being
  investigated upstream.

https://claude.ai/code/session_012gX4Kv5LjTEL2qonW8KYgC
</commit_message>
<xml_diff>
--- a/examples/real_world/_out/03_product_launch.pptx
+++ b/examples/real_world/_out/03_product_launch.pptx
@@ -4921,96 +4921,6 @@
   <p:transition xmlns:ns0="http://schemas.microsoft.com/office/powerpoint/2010/main" ns0:dur="1200">
     <ns0:morph/>
   </p:transition>
-  <p:timing>
-    <p:tnLst>
-      <p:par>
-        <p:cTn id="1" dur="indefinite" restart="never" nodeType="tmRoot">
-          <p:childTnLst>
-            <p:par>
-              <p:cTn fill="hold" id="2">
-                <p:stCondLst>
-                  <p:cond delay="0"/>
-                </p:stCondLst>
-                <p:childTnLst>
-                  <p:par>
-                    <p:cTn id="3" presetID="10" presetClass="entr" presetSubtype="0" fill="hold" grpId="0" nodeType="withEffect">
-                      <p:stCondLst>
-                        <p:cond delay="0"/>
-                      </p:stCondLst>
-                      <p:childTnLst>
-                        <p:set>
-                          <p:cBhvr>
-                            <p:cTn id="4" dur="1" fill="hold"/>
-                            <p:tgtEl>
-                              <p:spTgt spid="4"/>
-                            </p:tgtEl>
-                            <p:attrNameLst>
-                              <p:attrName>style.visibility</p:attrName>
-                            </p:attrNameLst>
-                          </p:cBhvr>
-                          <p:to>
-                            <p:strVal val="visible"/>
-                          </p:to>
-                        </p:set>
-                        <p:animEffect transition="in" filter="fade">
-                          <p:cBhvr>
-                            <p:cTn id="5" dur="500"/>
-                            <p:tgtEl>
-                              <p:spTgt spid="4"/>
-                            </p:tgtEl>
-                          </p:cBhvr>
-                        </p:animEffect>
-                      </p:childTnLst>
-                    </p:cTn>
-                  </p:par>
-                </p:childTnLst>
-              </p:cTn>
-            </p:par>
-            <p:par>
-              <p:cTn fill="hold" id="6">
-                <p:stCondLst>
-                  <p:cond delay="0"/>
-                </p:stCondLst>
-                <p:childTnLst>
-                  <p:par>
-                    <p:cTn id="7" presetID="10" presetClass="entr" presetSubtype="0" fill="hold" grpId="0" nodeType="afterEffect">
-                      <p:stCondLst>
-                        <p:cond delay="0"/>
-                      </p:stCondLst>
-                      <p:childTnLst>
-                        <p:set>
-                          <p:cBhvr>
-                            <p:cTn id="8" dur="1" fill="hold"/>
-                            <p:tgtEl>
-                              <p:spTgt spid="5"/>
-                            </p:tgtEl>
-                            <p:attrNameLst>
-                              <p:attrName>style.visibility</p:attrName>
-                            </p:attrNameLst>
-                          </p:cBhvr>
-                          <p:to>
-                            <p:strVal val="visible"/>
-                          </p:to>
-                        </p:set>
-                        <p:animEffect transition="in" filter="fade">
-                          <p:cBhvr>
-                            <p:cTn id="9" dur="500"/>
-                            <p:tgtEl>
-                              <p:spTgt spid="5"/>
-                            </p:tgtEl>
-                          </p:cBhvr>
-                        </p:animEffect>
-                      </p:childTnLst>
-                    </p:cTn>
-                  </p:par>
-                </p:childTnLst>
-              </p:cTn>
-            </p:par>
-          </p:childTnLst>
-        </p:cTn>
-      </p:par>
-    </p:tnLst>
-  </p:timing>
 </p:sld>
 </file>
 
@@ -6900,56 +6810,6 @@
   <p:transition xmlns:ns0="http://schemas.microsoft.com/office/powerpoint/2010/main" ns0:dur="400">
     <p:fade/>
   </p:transition>
-  <p:timing>
-    <p:tnLst>
-      <p:par>
-        <p:cTn id="1" dur="indefinite" restart="never" nodeType="tmRoot">
-          <p:childTnLst>
-            <p:par>
-              <p:cTn fill="hold" id="2">
-                <p:stCondLst>
-                  <p:cond delay="indefinite"/>
-                </p:stCondLst>
-                <p:childTnLst>
-                  <p:par>
-                    <p:cTn id="3" presetID="10" presetClass="entr" presetSubtype="0" fill="hold" grpId="0" nodeType="clickEffect">
-                      <p:stCondLst>
-                        <p:cond delay="0"/>
-                      </p:stCondLst>
-                      <p:childTnLst>
-                        <p:set>
-                          <p:cBhvr>
-                            <p:cTn id="4" dur="1" fill="hold"/>
-                            <p:tgtEl>
-                              <p:spTgt spid="5"/>
-                            </p:tgtEl>
-                            <p:attrNameLst>
-                              <p:attrName>style.visibility</p:attrName>
-                            </p:attrNameLst>
-                          </p:cBhvr>
-                          <p:to>
-                            <p:strVal val="visible"/>
-                          </p:to>
-                        </p:set>
-                        <p:animEffect transition="in" filter="fade">
-                          <p:cBhvr>
-                            <p:cTn id="5" dur="500"/>
-                            <p:tgtEl>
-                              <p:spTgt spid="5"/>
-                            </p:tgtEl>
-                          </p:cBhvr>
-                        </p:animEffect>
-                      </p:childTnLst>
-                    </p:cTn>
-                  </p:par>
-                </p:childTnLst>
-              </p:cTn>
-            </p:par>
-          </p:childTnLst>
-        </p:cTn>
-      </p:par>
-    </p:tnLst>
-  </p:timing>
 </p:sld>
 </file>
 

</xml_diff>